<commit_message>
Decks: sync equivalence-test framing (all 4)
External decks gain a plain 'statistically equivalent within +/-2 pts' line;
internal decks gain a dedicated statistical-rigor slide (76.2%->75.0%, TOST
p~1e-8) explaining why equivalence (not a plain significance test) is the
right tool at n=56k.
</commit_message>
<xml_diff>
--- a/docs/guardian_layer_deck.pptx
+++ b/docs/guardian_layer_deck.pptx
@@ -4017,11 +4017,30 @@
                 <a:spcPts val="0"/>
               </a:spcBef>
               <a:spcAft>
+                <a:spcPts val="1200"/>
+              </a:spcAft>
+            </a:pPr>
+            <a:r>
+              <a:rPr sz="1600" b="0" i="0">
+                <a:solidFill>
+                  <a:srgbClr val="0F6E5C"/>
+                </a:solidFill>
+                <a:latin typeface="Georgia"/>
+              </a:rPr>
+              <a:t>A statistical equivalence test confirms the change is too small to matter — within ±2 percentage points of no change at all.</a:t>
+            </a:r>
+          </a:p>
+          <a:p>
+            <a:pPr algn="l">
+              <a:spcBef>
+                <a:spcPts val="0"/>
+              </a:spcBef>
+              <a:spcAft>
                 <a:spcPts val="600"/>
               </a:spcAft>
             </a:pPr>
             <a:r>
-              <a:rPr sz="1600" b="0" i="0">
+              <a:rPr sz="1500" b="0" i="0">
                 <a:solidFill>
                   <a:srgbClr val="5C6B64"/>
                 </a:solidFill>

</xml_diff>

<commit_message>
Decks: minimal redesign — big numbers, one example per slide, no paragraphs
Stripped all multi-sentence prose. Each slide now carries a headline number/
phrase plus at most one before->after example. External 5 slides, internal 6;
ZH PDFs mirror. Fixed big-number/subtitle overlap in the PDF layout.
</commit_message>
<xml_diff>
--- a/docs/guardian_layer_deck.pptx
+++ b/docs/guardian_layer_deck.pptx
@@ -10,7 +10,6 @@
     <p:sldId id="258" r:id="rId9"/>
     <p:sldId id="259" r:id="rId10"/>
     <p:sldId id="260" r:id="rId11"/>
-    <p:sldId id="261" r:id="rId12"/>
   </p:sldIdLst>
   <p:sldSz cx="12191695" cy="6858000" type="screen4x3"/>
   <p:notesSz cx="6858000" cy="9144000"/>
@@ -3159,10 +3158,7 @@
           </a:bodyPr>
           <a:lstStyle/>
           <a:p>
-            <a:pPr algn="l">
-              <a:spcBef>
-                <a:spcPts val="0"/>
-              </a:spcBef>
+            <a:pPr>
               <a:spcAft>
                 <a:spcPts val="600"/>
               </a:spcAft>
@@ -3231,8 +3227,8 @@
         </p:nvSpPr>
         <p:spPr>
           <a:xfrm>
-            <a:off x="640080" y="2011680"/>
-            <a:ext cx="10881360" cy="2560320"/>
+            <a:off x="640080" y="2377440"/>
+            <a:ext cx="10881360" cy="2011680"/>
           </a:xfrm>
           <a:prstGeom prst="rect">
             <a:avLst/>
@@ -3245,146 +3241,35 @@
           </a:bodyPr>
           <a:lstStyle/>
           <a:p>
-            <a:pPr algn="l">
-              <a:spcBef>
-                <a:spcPts val="0"/>
-              </a:spcBef>
+            <a:pPr>
               <a:spcAft>
                 <a:spcPts val="200"/>
               </a:spcAft>
             </a:pPr>
             <a:r>
-              <a:rPr sz="4600" b="1" i="0">
+              <a:rPr sz="4400" b="1" i="0">
                 <a:solidFill>
                   <a:srgbClr val="18211E"/>
                 </a:solidFill>
                 <a:latin typeface="Georgia"/>
               </a:rPr>
-              <a:t>Does our privacy swap</a:t>
-            </a:r>
-          </a:p>
-          <a:p>
-            <a:pPr algn="l">
-              <a:spcBef>
-                <a:spcPts val="0"/>
-              </a:spcBef>
+              <a:t>Does the privacy swap</a:t>
+            </a:r>
+          </a:p>
+          <a:p>
+            <a:pPr>
               <a:spcAft>
-                <a:spcPts val="1800"/>
+                <a:spcPts val="600"/>
               </a:spcAft>
             </a:pPr>
             <a:r>
-              <a:rPr sz="4600" b="1" i="1">
+              <a:rPr sz="4400" b="1" i="1">
                 <a:solidFill>
                   <a:srgbClr val="0F6E5C"/>
                 </a:solidFill>
                 <a:latin typeface="Georgia"/>
               </a:rPr>
-              <a:t>keep the data usable?</a:t>
-            </a:r>
-          </a:p>
-          <a:p>
-            <a:pPr algn="l">
-              <a:spcBef>
-                <a:spcPts val="0"/>
-              </a:spcBef>
-              <a:spcAft>
-                <a:spcPts val="600"/>
-              </a:spcAft>
-            </a:pPr>
-            <a:r>
-              <a:rPr sz="2000" b="0" i="0">
-                <a:solidFill>
-                  <a:srgbClr val="5C6B64"/>
-                </a:solidFill>
-                <a:latin typeface="Georgia"/>
-              </a:rPr>
-              <a:t>We hide personal details by swapping them for realistic stand-ins. This is the test of whether anything downstream breaks.</a:t>
-            </a:r>
-          </a:p>
-        </p:txBody>
-      </p:sp>
-      <p:sp>
-        <p:nvSpPr>
-          <p:cNvPr id="6" name="Rectangle 5"/>
-          <p:cNvSpPr/>
-          <p:nvPr/>
-        </p:nvSpPr>
-        <p:spPr>
-          <a:xfrm>
-            <a:off x="640080" y="5943600"/>
-            <a:ext cx="10881360" cy="27940"/>
-          </a:xfrm>
-          <a:prstGeom prst="rect">
-            <a:avLst/>
-          </a:prstGeom>
-          <a:solidFill>
-            <a:srgbClr val="18211E"/>
-          </a:solidFill>
-          <a:ln>
-            <a:noFill/>
-          </a:ln>
-          <a:effectLst/>
-        </p:spPr>
-        <p:style>
-          <a:lnRef idx="1">
-            <a:schemeClr val="accent1"/>
-          </a:lnRef>
-          <a:fillRef idx="3">
-            <a:schemeClr val="accent1"/>
-          </a:fillRef>
-          <a:effectRef idx="2">
-            <a:schemeClr val="accent1"/>
-          </a:effectRef>
-          <a:fontRef idx="minor">
-            <a:schemeClr val="lt1"/>
-          </a:fontRef>
-        </p:style>
-        <p:txBody>
-          <a:bodyPr rtlCol="0" anchor="ctr"/>
-          <a:lstStyle/>
-          <a:p>
-            <a:pPr algn="ctr"/>
-          </a:p>
-        </p:txBody>
-      </p:sp>
-      <p:sp>
-        <p:nvSpPr>
-          <p:cNvPr id="7" name="TextBox 6"/>
-          <p:cNvSpPr txBox="1"/>
-          <p:nvPr/>
-        </p:nvSpPr>
-        <p:spPr>
-          <a:xfrm>
-            <a:off x="640080" y="6053328"/>
-            <a:ext cx="10881360" cy="457200"/>
-          </a:xfrm>
-          <a:prstGeom prst="rect">
-            <a:avLst/>
-          </a:prstGeom>
-          <a:noFill/>
-        </p:spPr>
-        <p:txBody>
-          <a:bodyPr wrap="square" lIns="0" rIns="0" tIns="0" bIns="0">
-            <a:spAutoFit/>
-          </a:bodyPr>
-          <a:lstStyle/>
-          <a:p>
-            <a:pPr algn="l">
-              <a:spcBef>
-                <a:spcPts val="0"/>
-              </a:spcBef>
-              <a:spcAft>
-                <a:spcPts val="600"/>
-              </a:spcAft>
-            </a:pPr>
-            <a:r>
-              <a:rPr sz="1300" b="0" i="0">
-                <a:solidFill>
-                  <a:srgbClr val="5C6B64"/>
-                </a:solidFill>
-                <a:latin typeface="Consolas"/>
-              </a:rPr>
-              <a:t>Tested on 1,750 real documents across 7 datasets and 7 languages.</a:t>
+              <a:t>keep data usable?</a:t>
             </a:r>
           </a:p>
         </p:txBody>
@@ -3473,10 +3358,7 @@
           </a:bodyPr>
           <a:lstStyle/>
           <a:p>
-            <a:pPr algn="l">
-              <a:spcBef>
-                <a:spcPts val="0"/>
-              </a:spcBef>
+            <a:pPr>
               <a:spcAft>
                 <a:spcPts val="600"/>
               </a:spcAft>
@@ -3488,7 +3370,7 @@
                 </a:solidFill>
                 <a:latin typeface="Consolas"/>
               </a:rPr>
-              <a:t>01 · WHAT THE TOOL DOES</a:t>
+              <a:t>01 · WHAT IT DOES</a:t>
             </a:r>
           </a:p>
         </p:txBody>
@@ -3545,8 +3427,8 @@
         </p:nvSpPr>
         <p:spPr>
           <a:xfrm>
-            <a:off x="640080" y="1280160"/>
-            <a:ext cx="10881360" cy="822960"/>
+            <a:off x="640080" y="1371600"/>
+            <a:ext cx="10881360" cy="548640"/>
           </a:xfrm>
           <a:prstGeom prst="rect">
             <a:avLst/>
@@ -3559,22 +3441,19 @@
           </a:bodyPr>
           <a:lstStyle/>
           <a:p>
-            <a:pPr algn="l">
-              <a:spcBef>
-                <a:spcPts val="0"/>
-              </a:spcBef>
+            <a:pPr>
               <a:spcAft>
                 <a:spcPts val="600"/>
               </a:spcAft>
             </a:pPr>
             <a:r>
-              <a:rPr sz="2400" b="1" i="0">
+              <a:rPr sz="2600" b="1" i="0">
                 <a:solidFill>
                   <a:srgbClr val="18211E"/>
                 </a:solidFill>
                 <a:latin typeface="Georgia"/>
               </a:rPr>
-              <a:t>It doesn’t black out personal info — it swaps it for a realistic fake of the same kind.</a:t>
+              <a:t>It swaps real info for a realistic fake.</a:t>
             </a:r>
           </a:p>
         </p:txBody>
@@ -3587,8 +3466,8 @@
         </p:nvSpPr>
         <p:spPr>
           <a:xfrm>
-            <a:off x="640080" y="2468880"/>
-            <a:ext cx="10881360" cy="2468880"/>
+            <a:off x="640080" y="2286000"/>
+            <a:ext cx="10881360" cy="1737360"/>
           </a:xfrm>
           <a:prstGeom prst="rect">
             <a:avLst/>
@@ -3634,7 +3513,7 @@
         <p:spPr>
           <a:xfrm>
             <a:off x="914400" y="2697480"/>
-            <a:ext cx="10332720" cy="2194560"/>
+            <a:ext cx="10332720" cy="1280160"/>
           </a:xfrm>
           <a:prstGeom prst="rect">
             <a:avLst/>
@@ -3647,98 +3526,35 @@
           </a:bodyPr>
           <a:lstStyle/>
           <a:p>
-            <a:pPr algn="l">
-              <a:spcBef>
-                <a:spcPts val="0"/>
-              </a:spcBef>
+            <a:pPr>
               <a:spcAft>
-                <a:spcPts val="600"/>
+                <a:spcPts val="1800"/>
               </a:spcAft>
             </a:pPr>
             <a:r>
-              <a:rPr sz="1100" b="1" i="0">
-                <a:solidFill>
-                  <a:srgbClr val="5C6B64"/>
-                </a:solidFill>
-                <a:latin typeface="Consolas"/>
-              </a:rPr>
-              <a:t>BEFORE</a:t>
-            </a:r>
-          </a:p>
-          <a:p>
-            <a:pPr algn="l">
-              <a:spcBef>
-                <a:spcPts val="0"/>
-              </a:spcBef>
-              <a:spcAft>
-                <a:spcPts val="1400"/>
-              </a:spcAft>
-            </a:pPr>
-            <a:r>
-              <a:rPr sz="1700" b="0" i="0">
+              <a:rPr sz="1800" b="0" i="0">
                 <a:solidFill>
                   <a:srgbClr val="BD5B36"/>
                 </a:solidFill>
                 <a:latin typeface="Consolas"/>
               </a:rPr>
-              <a:t>…a 34-year-old female treated by Anna S. at Methodist Hospital on April 12, 2023.</a:t>
-            </a:r>
-          </a:p>
-          <a:p>
-            <a:pPr algn="l">
-              <a:spcBef>
-                <a:spcPts val="0"/>
-              </a:spcBef>
+              <a:t>Anna S. ,  April 12 2023 ,  Methodist Hospital</a:t>
+            </a:r>
+          </a:p>
+          <a:p>
+            <a:pPr>
               <a:spcAft>
                 <a:spcPts val="600"/>
               </a:spcAft>
             </a:pPr>
             <a:r>
-              <a:rPr sz="1100" b="1" i="0">
-                <a:solidFill>
-                  <a:srgbClr val="5C6B64"/>
-                </a:solidFill>
-                <a:latin typeface="Consolas"/>
-              </a:rPr>
-              <a:t>AFTER</a:t>
-            </a:r>
-          </a:p>
-          <a:p>
-            <a:pPr algn="l">
-              <a:spcBef>
-                <a:spcPts val="0"/>
-              </a:spcBef>
-              <a:spcAft>
-                <a:spcPts val="1400"/>
-              </a:spcAft>
-            </a:pPr>
-            <a:r>
-              <a:rPr sz="1700" b="0" i="0">
+              <a:rPr sz="1800" b="0" i="0">
                 <a:solidFill>
                   <a:srgbClr val="0F6E5C"/>
                 </a:solidFill>
                 <a:latin typeface="Consolas"/>
               </a:rPr>
-              <a:t>…a 35-year-old female treated by Maria S. at Methodist Hospital on March 13, 2021.</a:t>
-            </a:r>
-          </a:p>
-          <a:p>
-            <a:pPr algn="l">
-              <a:spcBef>
-                <a:spcPts val="0"/>
-              </a:spcBef>
-              <a:spcAft>
-                <a:spcPts val="600"/>
-              </a:spcAft>
-            </a:pPr>
-            <a:r>
-              <a:rPr sz="1300" b="0" i="0">
-                <a:solidFill>
-                  <a:srgbClr val="5C6B64"/>
-                </a:solidFill>
-                <a:latin typeface="Georgia"/>
-              </a:rPr>
-              <a:t>Real name → fake name · real date → fake date. The sentence still reads normally, so anything that processed the original still works on the swapped version.</a:t>
+              <a:t>Maria S. ,  March 13 2021 ,  Methodist Hospital</a:t>
             </a:r>
           </a:p>
         </p:txBody>
@@ -3827,10 +3643,7 @@
           </a:bodyPr>
           <a:lstStyle/>
           <a:p>
-            <a:pPr algn="l">
-              <a:spcBef>
-                <a:spcPts val="0"/>
-              </a:spcBef>
+            <a:pPr>
               <a:spcAft>
                 <a:spcPts val="600"/>
               </a:spcAft>
@@ -3899,8 +3712,8 @@
         </p:nvSpPr>
         <p:spPr>
           <a:xfrm>
-            <a:off x="640080" y="1828800"/>
-            <a:ext cx="4937760" cy="2743200"/>
+            <a:off x="640080" y="2103120"/>
+            <a:ext cx="6400800" cy="2194560"/>
           </a:xfrm>
           <a:prstGeom prst="rect">
             <a:avLst/>
@@ -3913,16 +3726,13 @@
           </a:bodyPr>
           <a:lstStyle/>
           <a:p>
-            <a:pPr algn="l">
-              <a:spcBef>
-                <a:spcPts val="0"/>
-              </a:spcBef>
+            <a:pPr>
               <a:spcAft>
-                <a:spcPts val="800"/>
+                <a:spcPts val="600"/>
               </a:spcAft>
             </a:pPr>
             <a:r>
-              <a:rPr sz="8000" b="1" i="0">
+              <a:rPr sz="9600" b="1" i="0">
                 <a:solidFill>
                   <a:srgbClr val="0F6E5C"/>
                 </a:solidFill>
@@ -3932,22 +3742,19 @@
             </a:r>
           </a:p>
           <a:p>
-            <a:pPr algn="l">
-              <a:spcBef>
-                <a:spcPts val="0"/>
-              </a:spcBef>
+            <a:pPr>
               <a:spcAft>
                 <a:spcPts val="600"/>
               </a:spcAft>
             </a:pPr>
             <a:r>
-              <a:rPr sz="1300" b="1" i="0">
+              <a:rPr sz="1800" b="0" i="0">
                 <a:solidFill>
                   <a:srgbClr val="5C6B64"/>
                 </a:solidFill>
-                <a:latin typeface="Consolas"/>
+                <a:latin typeface="Georgia"/>
               </a:rPr>
-              <a:t>OF THE TIME, THE SWAPPED INFO IS STILL FOUND</a:t>
+              <a:t>the swapped info is still found</a:t>
             </a:r>
           </a:p>
         </p:txBody>
@@ -3960,8 +3767,8 @@
         </p:nvSpPr>
         <p:spPr>
           <a:xfrm>
-            <a:off x="5852160" y="1920240"/>
-            <a:ext cx="5669280" cy="2926080"/>
+            <a:off x="7315200" y="2468880"/>
+            <a:ext cx="4206240" cy="1828800"/>
           </a:xfrm>
           <a:prstGeom prst="rect">
             <a:avLst/>
@@ -3974,79 +3781,35 @@
           </a:bodyPr>
           <a:lstStyle/>
           <a:p>
-            <a:pPr algn="l">
-              <a:spcBef>
-                <a:spcPts val="0"/>
-              </a:spcBef>
+            <a:pPr>
               <a:spcAft>
-                <a:spcPts val="1400"/>
+                <a:spcPts val="200"/>
               </a:spcAft>
             </a:pPr>
             <a:r>
-              <a:rPr sz="2400" b="1" i="0">
+              <a:rPr sz="1900" b="1" i="0">
                 <a:solidFill>
                   <a:srgbClr val="18211E"/>
                 </a:solidFill>
                 <a:latin typeface="Georgia"/>
               </a:rPr>
-              <a:t>The swap doesn’t hide the data from other tools.</a:t>
-            </a:r>
-          </a:p>
-          <a:p>
-            <a:pPr algn="l">
-              <a:spcBef>
-                <a:spcPts val="0"/>
-              </a:spcBef>
+              <a:t>Change is statistically</a:t>
+            </a:r>
+          </a:p>
+          <a:p>
+            <a:pPr>
               <a:spcAft>
-                <a:spcPts val="1200"/>
+                <a:spcPts val="600"/>
               </a:spcAft>
             </a:pPr>
             <a:r>
-              <a:rPr sz="1800" b="0" i="0">
+              <a:rPr sz="1900" b="0" i="0">
                 <a:solidFill>
                   <a:srgbClr val="18211E"/>
                 </a:solidFill>
                 <a:latin typeface="Georgia"/>
               </a:rPr>
-              <a:t>After swapping, other AI tools still spot the sensitive details — in the same place, almost every time. We checked this across 11 different tools (GPT-5, Gemma, Qwen, Llama 8B/70B, DeepSeek, Presidio, OBI).</a:t>
-            </a:r>
-          </a:p>
-          <a:p>
-            <a:pPr algn="l">
-              <a:spcBef>
-                <a:spcPts val="0"/>
-              </a:spcBef>
-              <a:spcAft>
-                <a:spcPts val="1200"/>
-              </a:spcAft>
-            </a:pPr>
-            <a:r>
-              <a:rPr sz="1600" b="0" i="0">
-                <a:solidFill>
-                  <a:srgbClr val="0F6E5C"/>
-                </a:solidFill>
-                <a:latin typeface="Georgia"/>
-              </a:rPr>
-              <a:t>A statistical equivalence test confirms the change is too small to matter — within ±2 percentage points of no change at all.</a:t>
-            </a:r>
-          </a:p>
-          <a:p>
-            <a:pPr algn="l">
-              <a:spcBef>
-                <a:spcPts val="0"/>
-              </a:spcBef>
-              <a:spcAft>
-                <a:spcPts val="600"/>
-              </a:spcAft>
-            </a:pPr>
-            <a:r>
-              <a:rPr sz="1500" b="0" i="0">
-                <a:solidFill>
-                  <a:srgbClr val="5C6B64"/>
-                </a:solidFill>
-                <a:latin typeface="Georgia"/>
-              </a:rPr>
-              <a:t>And the structure is untouched: medical notes, forms, even raw data files keep their exact format. Nothing downstream breaks.</a:t>
+              <a:t>negligible — within ±2 pts.</a:t>
             </a:r>
           </a:p>
         </p:txBody>
@@ -4135,10 +3898,7 @@
           </a:bodyPr>
           <a:lstStyle/>
           <a:p>
-            <a:pPr algn="l">
-              <a:spcBef>
-                <a:spcPts val="0"/>
-              </a:spcBef>
+            <a:pPr>
               <a:spcAft>
                 <a:spcPts val="600"/>
               </a:spcAft>
@@ -4150,7 +3910,7 @@
                 </a:solidFill>
                 <a:latin typeface="Consolas"/>
               </a:rPr>
-              <a:t>03 · IT HOLDS ACROSS FORMATS &amp; LANGUAGES</a:t>
+              <a:t>03 · HOLDS ACROSS FORMATS &amp; LANGUAGES</a:t>
             </a:r>
           </a:p>
         </p:txBody>
@@ -4201,60 +3961,14 @@
       </p:sp>
       <p:sp>
         <p:nvSpPr>
-          <p:cNvPr id="5" name="Rectangle 4"/>
-          <p:cNvSpPr/>
-          <p:nvPr/>
-        </p:nvSpPr>
-        <p:spPr>
-          <a:xfrm>
-            <a:off x="640080" y="1234440"/>
-            <a:ext cx="10881360" cy="1508760"/>
-          </a:xfrm>
-          <a:prstGeom prst="rect">
-            <a:avLst/>
-          </a:prstGeom>
-          <a:solidFill>
-            <a:srgbClr val="F3F5F3"/>
-          </a:solidFill>
-          <a:ln w="12700">
-            <a:solidFill>
-              <a:srgbClr val="C5CDC8"/>
-            </a:solidFill>
-          </a:ln>
-          <a:effectLst/>
-        </p:spPr>
-        <p:style>
-          <a:lnRef idx="1">
-            <a:schemeClr val="accent1"/>
-          </a:lnRef>
-          <a:fillRef idx="3">
-            <a:schemeClr val="accent1"/>
-          </a:fillRef>
-          <a:effectRef idx="2">
-            <a:schemeClr val="accent1"/>
-          </a:effectRef>
-          <a:fontRef idx="minor">
-            <a:schemeClr val="lt1"/>
-          </a:fontRef>
-        </p:style>
-        <p:txBody>
-          <a:bodyPr rtlCol="0" anchor="ctr"/>
-          <a:lstStyle/>
-          <a:p>
-            <a:pPr algn="ctr"/>
-          </a:p>
-        </p:txBody>
-      </p:sp>
-      <p:sp>
-        <p:nvSpPr>
-          <p:cNvPr id="6" name="TextBox 5"/>
+          <p:cNvPr id="5" name="TextBox 4"/>
           <p:cNvSpPr txBox="1"/>
           <p:nvPr/>
         </p:nvSpPr>
         <p:spPr>
           <a:xfrm>
-            <a:off x="868680" y="1353312"/>
-            <a:ext cx="10424160" cy="1371600"/>
+            <a:off x="640080" y="1554480"/>
+            <a:ext cx="10881360" cy="548640"/>
           </a:xfrm>
           <a:prstGeom prst="rect">
             <a:avLst/>
@@ -4267,369 +3981,184 @@
           </a:bodyPr>
           <a:lstStyle/>
           <a:p>
-            <a:pPr algn="l">
-              <a:spcBef>
-                <a:spcPts val="0"/>
-              </a:spcBef>
+            <a:pPr>
               <a:spcAft>
-                <a:spcPts val="500"/>
+                <a:spcPts val="200"/>
               </a:spcAft>
             </a:pPr>
             <a:r>
-              <a:rPr sz="1100" b="1" i="0">
-                <a:solidFill>
-                  <a:srgbClr val="5C6B64"/>
-                </a:solidFill>
-                <a:latin typeface="Consolas"/>
-              </a:rPr>
-              <a:t>DOCTOR’S SHORTHAND NOTE</a:t>
-            </a:r>
-          </a:p>
-          <a:p>
-            <a:pPr algn="l">
-              <a:spcBef>
-                <a:spcPts val="0"/>
-              </a:spcBef>
-              <a:spcAft>
-                <a:spcPts val="300"/>
-              </a:spcAft>
-            </a:pPr>
-            <a:r>
-              <a:rPr sz="1250" b="0" i="0">
+              <a:rPr sz="1500" b="0" i="0">
                 <a:solidFill>
                   <a:srgbClr val="BD5B36"/>
                 </a:solidFill>
                 <a:latin typeface="Consolas"/>
               </a:rPr>
-              <a:t>before   70yo M, seen by Dr. John L. at Mt. Sinai on Feb 21, 2023</a:t>
-            </a:r>
-          </a:p>
-          <a:p>
-            <a:pPr algn="l">
-              <a:spcBef>
-                <a:spcPts val="0"/>
-              </a:spcBef>
+              <a:t>70yo M, Dr. John L., Mt. Sinai, Feb 21 2023</a:t>
+            </a:r>
+          </a:p>
+          <a:p>
+            <a:pPr>
               <a:spcAft>
-                <a:spcPts val="400"/>
+                <a:spcPts val="600"/>
               </a:spcAft>
             </a:pPr>
             <a:r>
-              <a:rPr sz="1250" b="0" i="0">
+              <a:rPr sz="1500" b="0" i="0">
                 <a:solidFill>
                   <a:srgbClr val="0F6E5C"/>
                 </a:solidFill>
                 <a:latin typeface="Consolas"/>
               </a:rPr>
-              <a:t>after    73 yo M, seen by Dr. James L. at Mt. Egypt on Nov 19, 2021</a:t>
-            </a:r>
-          </a:p>
-          <a:p>
-            <a:pPr algn="l">
-              <a:spcBef>
-                <a:spcPts val="0"/>
-              </a:spcBef>
+              <a:t>73yo M, Dr. James L., Mt. Egypt, Nov 19 2021</a:t>
+            </a:r>
+          </a:p>
+        </p:txBody>
+      </p:sp>
+      <p:sp>
+        <p:nvSpPr>
+          <p:cNvPr id="6" name="TextBox 5"/>
+          <p:cNvSpPr txBox="1"/>
+          <p:nvPr/>
+        </p:nvSpPr>
+        <p:spPr>
+          <a:xfrm>
+            <a:off x="640080" y="2926080"/>
+            <a:ext cx="10881360" cy="548640"/>
+          </a:xfrm>
+          <a:prstGeom prst="rect">
+            <a:avLst/>
+          </a:prstGeom>
+          <a:noFill/>
+        </p:spPr>
+        <p:txBody>
+          <a:bodyPr wrap="square" lIns="0" rIns="0" tIns="0" bIns="0">
+            <a:spAutoFit/>
+          </a:bodyPr>
+          <a:lstStyle/>
+          <a:p>
+            <a:pPr>
+              <a:spcAft>
+                <a:spcPts val="200"/>
+              </a:spcAft>
+            </a:pPr>
+            <a:r>
+              <a:rPr sz="1500" b="0" i="0">
+                <a:solidFill>
+                  <a:srgbClr val="BD5B36"/>
+                </a:solidFill>
+                <a:latin typeface="Consolas"/>
+              </a:rPr>
+              <a:t>German:  ... Monsignore ... 23/07/2011</a:t>
+            </a:r>
+          </a:p>
+          <a:p>
+            <a:pPr>
               <a:spcAft>
                 <a:spcPts val="600"/>
               </a:spcAft>
             </a:pPr>
             <a:r>
-              <a:rPr sz="1100" b="0" i="0">
+              <a:rPr sz="1500" b="0" i="0">
+                <a:solidFill>
+                  <a:srgbClr val="0F6E5C"/>
+                </a:solidFill>
+                <a:latin typeface="Consolas"/>
+              </a:rPr>
+              <a:t>        ... Fulgenzio ... 24/07/2011</a:t>
+            </a:r>
+          </a:p>
+        </p:txBody>
+      </p:sp>
+      <p:sp>
+        <p:nvSpPr>
+          <p:cNvPr id="7" name="TextBox 6"/>
+          <p:cNvSpPr txBox="1"/>
+          <p:nvPr/>
+        </p:nvSpPr>
+        <p:spPr>
+          <a:xfrm>
+            <a:off x="640080" y="4297680"/>
+            <a:ext cx="10881360" cy="548640"/>
+          </a:xfrm>
+          <a:prstGeom prst="rect">
+            <a:avLst/>
+          </a:prstGeom>
+          <a:noFill/>
+        </p:spPr>
+        <p:txBody>
+          <a:bodyPr wrap="square" lIns="0" rIns="0" tIns="0" bIns="0">
+            <a:spAutoFit/>
+          </a:bodyPr>
+          <a:lstStyle/>
+          <a:p>
+            <a:pPr>
+              <a:spcAft>
+                <a:spcPts val="200"/>
+              </a:spcAft>
+            </a:pPr>
+            <a:r>
+              <a:rPr sz="1500" b="0" i="0">
+                <a:solidFill>
+                  <a:srgbClr val="BD5B36"/>
+                </a:solidFill>
+                <a:latin typeface="Consolas"/>
+              </a:rPr>
+              <a:t>JSON:  {"Date":"20/05/2022","City":"Saint-Priest"}</a:t>
+            </a:r>
+          </a:p>
+          <a:p>
+            <a:pPr>
+              <a:spcAft>
+                <a:spcPts val="600"/>
+              </a:spcAft>
+            </a:pPr>
+            <a:r>
+              <a:rPr sz="1500" b="0" i="0">
+                <a:solidFill>
+                  <a:srgbClr val="0F6E5C"/>
+                </a:solidFill>
+                <a:latin typeface="Consolas"/>
+              </a:rPr>
+              <a:t>       {"Date":"21/05/2023","City":"Saint-Priest"}</a:t>
+            </a:r>
+          </a:p>
+        </p:txBody>
+      </p:sp>
+      <p:sp>
+        <p:nvSpPr>
+          <p:cNvPr id="8" name="TextBox 7"/>
+          <p:cNvSpPr txBox="1"/>
+          <p:nvPr/>
+        </p:nvSpPr>
+        <p:spPr>
+          <a:xfrm>
+            <a:off x="640080" y="5486400"/>
+            <a:ext cx="10881360" cy="457200"/>
+          </a:xfrm>
+          <a:prstGeom prst="rect">
+            <a:avLst/>
+          </a:prstGeom>
+          <a:noFill/>
+        </p:spPr>
+        <p:txBody>
+          <a:bodyPr wrap="square" lIns="0" rIns="0" tIns="0" bIns="0">
+            <a:spAutoFit/>
+          </a:bodyPr>
+          <a:lstStyle/>
+          <a:p>
+            <a:pPr>
+              <a:spcAft>
+                <a:spcPts val="600"/>
+              </a:spcAft>
+            </a:pPr>
+            <a:r>
+              <a:rPr sz="1500" b="0" i="0">
                 <a:solidFill>
                   <a:srgbClr val="5C6B64"/>
                 </a:solidFill>
                 <a:latin typeface="Georgia"/>
               </a:rPr>
-              <a:t>Even messy clinical abbreviations stay intact — only the personal details change.</a:t>
-            </a:r>
-          </a:p>
-        </p:txBody>
-      </p:sp>
-      <p:sp>
-        <p:nvSpPr>
-          <p:cNvPr id="7" name="Rectangle 6"/>
-          <p:cNvSpPr/>
-          <p:nvPr/>
-        </p:nvSpPr>
-        <p:spPr>
-          <a:xfrm>
-            <a:off x="640080" y="2971800"/>
-            <a:ext cx="10881360" cy="1508760"/>
-          </a:xfrm>
-          <a:prstGeom prst="rect">
-            <a:avLst/>
-          </a:prstGeom>
-          <a:solidFill>
-            <a:srgbClr val="F3F5F3"/>
-          </a:solidFill>
-          <a:ln w="12700">
-            <a:solidFill>
-              <a:srgbClr val="C5CDC8"/>
-            </a:solidFill>
-          </a:ln>
-          <a:effectLst/>
-        </p:spPr>
-        <p:style>
-          <a:lnRef idx="1">
-            <a:schemeClr val="accent1"/>
-          </a:lnRef>
-          <a:fillRef idx="3">
-            <a:schemeClr val="accent1"/>
-          </a:fillRef>
-          <a:effectRef idx="2">
-            <a:schemeClr val="accent1"/>
-          </a:effectRef>
-          <a:fontRef idx="minor">
-            <a:schemeClr val="lt1"/>
-          </a:fontRef>
-        </p:style>
-        <p:txBody>
-          <a:bodyPr rtlCol="0" anchor="ctr"/>
-          <a:lstStyle/>
-          <a:p>
-            <a:pPr algn="ctr"/>
-          </a:p>
-        </p:txBody>
-      </p:sp>
-      <p:sp>
-        <p:nvSpPr>
-          <p:cNvPr id="8" name="TextBox 7"/>
-          <p:cNvSpPr txBox="1"/>
-          <p:nvPr/>
-        </p:nvSpPr>
-        <p:spPr>
-          <a:xfrm>
-            <a:off x="868680" y="3090672"/>
-            <a:ext cx="10424160" cy="1371600"/>
-          </a:xfrm>
-          <a:prstGeom prst="rect">
-            <a:avLst/>
-          </a:prstGeom>
-          <a:noFill/>
-        </p:spPr>
-        <p:txBody>
-          <a:bodyPr wrap="square" lIns="0" rIns="0" tIns="0" bIns="0">
-            <a:spAutoFit/>
-          </a:bodyPr>
-          <a:lstStyle/>
-          <a:p>
-            <a:pPr algn="l">
-              <a:spcBef>
-                <a:spcPts val="0"/>
-              </a:spcBef>
-              <a:spcAft>
-                <a:spcPts val="500"/>
-              </a:spcAft>
-            </a:pPr>
-            <a:r>
-              <a:rPr sz="1100" b="1" i="0">
-                <a:solidFill>
-                  <a:srgbClr val="5C6B64"/>
-                </a:solidFill>
-                <a:latin typeface="Consolas"/>
-              </a:rPr>
-              <a:t>GERMAN RECORD</a:t>
-            </a:r>
-          </a:p>
-          <a:p>
-            <a:pPr algn="l">
-              <a:spcBef>
-                <a:spcPts val="0"/>
-              </a:spcBef>
-              <a:spcAft>
-                <a:spcPts val="300"/>
-              </a:spcAft>
-            </a:pPr>
-            <a:r>
-              <a:rPr sz="1250" b="0" i="0">
-                <a:solidFill>
-                  <a:srgbClr val="BD5B36"/>
-                </a:solidFill>
-                <a:latin typeface="Consolas"/>
-              </a:rPr>
-              <a:t>before   …ermächtigen hiermit Monsignore … Mit Datum 23/07/2011</a:t>
-            </a:r>
-          </a:p>
-          <a:p>
-            <a:pPr algn="l">
-              <a:spcBef>
-                <a:spcPts val="0"/>
-              </a:spcBef>
-              <a:spcAft>
-                <a:spcPts val="400"/>
-              </a:spcAft>
-            </a:pPr>
-            <a:r>
-              <a:rPr sz="1250" b="0" i="0">
-                <a:solidFill>
-                  <a:srgbClr val="0F6E5C"/>
-                </a:solidFill>
-                <a:latin typeface="Consolas"/>
-              </a:rPr>
-              <a:t>after    …ermächtigen hiermit Fulgenzio … Mit Datum 24/07/2011</a:t>
-            </a:r>
-          </a:p>
-          <a:p>
-            <a:pPr algn="l">
-              <a:spcBef>
-                <a:spcPts val="0"/>
-              </a:spcBef>
-              <a:spcAft>
-                <a:spcPts val="600"/>
-              </a:spcAft>
-            </a:pPr>
-            <a:r>
-              <a:rPr sz="1100" b="0" i="0">
-                <a:solidFill>
-                  <a:srgbClr val="5C6B64"/>
-                </a:solidFill>
-                <a:latin typeface="Georgia"/>
-              </a:rPr>
-              <a:t>Works the same across languages.</a:t>
-            </a:r>
-          </a:p>
-        </p:txBody>
-      </p:sp>
-      <p:sp>
-        <p:nvSpPr>
-          <p:cNvPr id="9" name="Rectangle 8"/>
-          <p:cNvSpPr/>
-          <p:nvPr/>
-        </p:nvSpPr>
-        <p:spPr>
-          <a:xfrm>
-            <a:off x="640080" y="4709160"/>
-            <a:ext cx="10881360" cy="1508760"/>
-          </a:xfrm>
-          <a:prstGeom prst="rect">
-            <a:avLst/>
-          </a:prstGeom>
-          <a:solidFill>
-            <a:srgbClr val="F3F5F3"/>
-          </a:solidFill>
-          <a:ln w="12700">
-            <a:solidFill>
-              <a:srgbClr val="C5CDC8"/>
-            </a:solidFill>
-          </a:ln>
-          <a:effectLst/>
-        </p:spPr>
-        <p:style>
-          <a:lnRef idx="1">
-            <a:schemeClr val="accent1"/>
-          </a:lnRef>
-          <a:fillRef idx="3">
-            <a:schemeClr val="accent1"/>
-          </a:fillRef>
-          <a:effectRef idx="2">
-            <a:schemeClr val="accent1"/>
-          </a:effectRef>
-          <a:fontRef idx="minor">
-            <a:schemeClr val="lt1"/>
-          </a:fontRef>
-        </p:style>
-        <p:txBody>
-          <a:bodyPr rtlCol="0" anchor="ctr"/>
-          <a:lstStyle/>
-          <a:p>
-            <a:pPr algn="ctr"/>
-          </a:p>
-        </p:txBody>
-      </p:sp>
-      <p:sp>
-        <p:nvSpPr>
-          <p:cNvPr id="10" name="TextBox 9"/>
-          <p:cNvSpPr txBox="1"/>
-          <p:nvPr/>
-        </p:nvSpPr>
-        <p:spPr>
-          <a:xfrm>
-            <a:off x="868680" y="4828032"/>
-            <a:ext cx="10424160" cy="1371600"/>
-          </a:xfrm>
-          <a:prstGeom prst="rect">
-            <a:avLst/>
-          </a:prstGeom>
-          <a:noFill/>
-        </p:spPr>
-        <p:txBody>
-          <a:bodyPr wrap="square" lIns="0" rIns="0" tIns="0" bIns="0">
-            <a:spAutoFit/>
-          </a:bodyPr>
-          <a:lstStyle/>
-          <a:p>
-            <a:pPr algn="l">
-              <a:spcBef>
-                <a:spcPts val="0"/>
-              </a:spcBef>
-              <a:spcAft>
-                <a:spcPts val="500"/>
-              </a:spcAft>
-            </a:pPr>
-            <a:r>
-              <a:rPr sz="1100" b="1" i="0">
-                <a:solidFill>
-                  <a:srgbClr val="5C6B64"/>
-                </a:solidFill>
-                <a:latin typeface="Consolas"/>
-              </a:rPr>
-              <a:t>A RAW DATA FILE (JSON)</a:t>
-            </a:r>
-          </a:p>
-          <a:p>
-            <a:pPr algn="l">
-              <a:spcBef>
-                <a:spcPts val="0"/>
-              </a:spcBef>
-              <a:spcAft>
-                <a:spcPts val="300"/>
-              </a:spcAft>
-            </a:pPr>
-            <a:r>
-              <a:rPr sz="1250" b="0" i="0">
-                <a:solidFill>
-                  <a:srgbClr val="BD5B36"/>
-                </a:solidFill>
-                <a:latin typeface="Consolas"/>
-              </a:rPr>
-              <a:t>before   { "Date": "20/05/2022", "City": "Saint-Priest", "User": "phprosdocimo" }</a:t>
-            </a:r>
-          </a:p>
-          <a:p>
-            <a:pPr algn="l">
-              <a:spcBef>
-                <a:spcPts val="0"/>
-              </a:spcBef>
-              <a:spcAft>
-                <a:spcPts val="400"/>
-              </a:spcAft>
-            </a:pPr>
-            <a:r>
-              <a:rPr sz="1250" b="0" i="0">
-                <a:solidFill>
-                  <a:srgbClr val="0F6E5C"/>
-                </a:solidFill>
-                <a:latin typeface="Consolas"/>
-              </a:rPr>
-              <a:t>after    { "Date": "21/05/2023", "City": "Saint-Priest", "User": "phprosdocimo" }</a:t>
-            </a:r>
-          </a:p>
-          <a:p>
-            <a:pPr algn="l">
-              <a:spcBef>
-                <a:spcPts val="0"/>
-              </a:spcBef>
-              <a:spcAft>
-                <a:spcPts val="600"/>
-              </a:spcAft>
-            </a:pPr>
-            <a:r>
-              <a:rPr sz="1100" b="0" i="0">
-                <a:solidFill>
-                  <a:srgbClr val="5C6B64"/>
-                </a:solidFill>
-                <a:latin typeface="Georgia"/>
-              </a:rPr>
-              <a:t>The file format is preserved exactly — only the private value is swapped, so systems that read it never break.</a:t>
+              <a:t>Only the private value changes — the format stays exact.</a:t>
             </a:r>
           </a:p>
         </p:txBody>
@@ -4667,7 +4196,7 @@
             <a:avLst/>
           </a:prstGeom>
           <a:solidFill>
-            <a:srgbClr val="E9ECEA"/>
+            <a:srgbClr val="18211E"/>
           </a:solidFill>
           <a:ln>
             <a:noFill/>
@@ -4704,8 +4233,8 @@
         </p:nvSpPr>
         <p:spPr>
           <a:xfrm>
-            <a:off x="640080" y="502920"/>
-            <a:ext cx="10881360" cy="365760"/>
+            <a:off x="822960" y="2743200"/>
+            <a:ext cx="10515600" cy="1463040"/>
           </a:xfrm>
           <a:prstGeom prst="rect">
             <a:avLst/>
@@ -4718,521 +4247,74 @@
           </a:bodyPr>
           <a:lstStyle/>
           <a:p>
-            <a:pPr algn="l">
-              <a:spcBef>
-                <a:spcPts val="0"/>
-              </a:spcBef>
+            <a:pPr>
+              <a:spcAft>
+                <a:spcPts val="400"/>
+              </a:spcAft>
+            </a:pPr>
+            <a:r>
+              <a:rPr sz="3600" b="1" i="0">
+                <a:solidFill>
+                  <a:srgbClr val="FFFFFF"/>
+                </a:solidFill>
+                <a:latin typeface="Georgia"/>
+              </a:rPr>
+              <a:t>Protects privacy.</a:t>
+            </a:r>
+          </a:p>
+          <a:p>
+            <a:pPr>
               <a:spcAft>
                 <a:spcPts val="600"/>
               </a:spcAft>
             </a:pPr>
             <a:r>
-              <a:rPr sz="1200" b="1" i="0">
+              <a:rPr sz="3600" b="1" i="1">
+                <a:solidFill>
+                  <a:srgbClr val="0F6E5C"/>
+                </a:solidFill>
+                <a:latin typeface="Georgia"/>
+              </a:rPr>
+              <a:t>Doesn’t break the data.</a:t>
+            </a:r>
+          </a:p>
+        </p:txBody>
+      </p:sp>
+      <p:sp>
+        <p:nvSpPr>
+          <p:cNvPr id="4" name="TextBox 3"/>
+          <p:cNvSpPr txBox="1"/>
+          <p:nvPr/>
+        </p:nvSpPr>
+        <p:spPr>
+          <a:xfrm>
+            <a:off x="822960" y="5486400"/>
+            <a:ext cx="10515600" cy="457200"/>
+          </a:xfrm>
+          <a:prstGeom prst="rect">
+            <a:avLst/>
+          </a:prstGeom>
+          <a:noFill/>
+        </p:spPr>
+        <p:txBody>
+          <a:bodyPr wrap="square" lIns="0" rIns="0" tIns="0" bIns="0">
+            <a:spAutoFit/>
+          </a:bodyPr>
+          <a:lstStyle/>
+          <a:p>
+            <a:pPr>
+              <a:spcAft>
+                <a:spcPts val="600"/>
+              </a:spcAft>
+            </a:pPr>
+            <a:r>
+              <a:rPr sz="1600" b="1" i="0">
                 <a:solidFill>
                   <a:srgbClr val="0F6E5C"/>
                 </a:solidFill>
                 <a:latin typeface="Consolas"/>
               </a:rPr>
-              <a:t>04 · ONE HONEST NOTE</a:t>
-            </a:r>
-          </a:p>
-        </p:txBody>
-      </p:sp>
-      <p:sp>
-        <p:nvSpPr>
-          <p:cNvPr id="4" name="Rectangle 3"/>
-          <p:cNvSpPr/>
-          <p:nvPr/>
-        </p:nvSpPr>
-        <p:spPr>
-          <a:xfrm>
-            <a:off x="640080" y="914400"/>
-            <a:ext cx="10881360" cy="27940"/>
-          </a:xfrm>
-          <a:prstGeom prst="rect">
-            <a:avLst/>
-          </a:prstGeom>
-          <a:solidFill>
-            <a:srgbClr val="18211E"/>
-          </a:solidFill>
-          <a:ln>
-            <a:noFill/>
-          </a:ln>
-          <a:effectLst/>
-        </p:spPr>
-        <p:style>
-          <a:lnRef idx="1">
-            <a:schemeClr val="accent1"/>
-          </a:lnRef>
-          <a:fillRef idx="3">
-            <a:schemeClr val="accent1"/>
-          </a:fillRef>
-          <a:effectRef idx="2">
-            <a:schemeClr val="accent1"/>
-          </a:effectRef>
-          <a:fontRef idx="minor">
-            <a:schemeClr val="lt1"/>
-          </a:fontRef>
-        </p:style>
-        <p:txBody>
-          <a:bodyPr rtlCol="0" anchor="ctr"/>
-          <a:lstStyle/>
-          <a:p>
-            <a:pPr algn="ctr"/>
-          </a:p>
-        </p:txBody>
-      </p:sp>
-      <p:sp>
-        <p:nvSpPr>
-          <p:cNvPr id="5" name="TextBox 4"/>
-          <p:cNvSpPr txBox="1"/>
-          <p:nvPr/>
-        </p:nvSpPr>
-        <p:spPr>
-          <a:xfrm>
-            <a:off x="640080" y="1463040"/>
-            <a:ext cx="10881360" cy="1280160"/>
-          </a:xfrm>
-          <a:prstGeom prst="rect">
-            <a:avLst/>
-          </a:prstGeom>
-          <a:noFill/>
-        </p:spPr>
-        <p:txBody>
-          <a:bodyPr wrap="square" lIns="0" rIns="0" tIns="0" bIns="0">
-            <a:spAutoFit/>
-          </a:bodyPr>
-          <a:lstStyle/>
-          <a:p>
-            <a:pPr algn="l">
-              <a:spcBef>
-                <a:spcPts val="0"/>
-              </a:spcBef>
-              <a:spcAft>
-                <a:spcPts val="1200"/>
-              </a:spcAft>
-            </a:pPr>
-            <a:r>
-              <a:rPr sz="2600" b="1" i="0">
-                <a:solidFill>
-                  <a:srgbClr val="18211E"/>
-                </a:solidFill>
-                <a:latin typeface="Georgia"/>
-              </a:rPr>
-              <a:t>How much it swaps depends on the data.</a:t>
-            </a:r>
-          </a:p>
-          <a:p>
-            <a:pPr algn="l">
-              <a:spcBef>
-                <a:spcPts val="0"/>
-              </a:spcBef>
-              <a:spcAft>
-                <a:spcPts val="600"/>
-              </a:spcAft>
-            </a:pPr>
-            <a:r>
-              <a:rPr sz="1800" b="0" i="0">
-                <a:solidFill>
-                  <a:srgbClr val="5C6B64"/>
-                </a:solidFill>
-                <a:latin typeface="Georgia"/>
-              </a:rPr>
-              <a:t>The tool is tuned for genuinely private information. On real medical records it swaps most of it; on general text it swaps less, because many names there aren’t actually private.</a:t>
-            </a:r>
-          </a:p>
-        </p:txBody>
-      </p:sp>
-      <p:sp>
-        <p:nvSpPr>
-          <p:cNvPr id="6" name="TextBox 5"/>
-          <p:cNvSpPr txBox="1"/>
-          <p:nvPr/>
-        </p:nvSpPr>
-        <p:spPr>
-          <a:xfrm>
-            <a:off x="822960" y="3383280"/>
-            <a:ext cx="5486400" cy="548640"/>
-          </a:xfrm>
-          <a:prstGeom prst="rect">
-            <a:avLst/>
-          </a:prstGeom>
-          <a:noFill/>
-        </p:spPr>
-        <p:txBody>
-          <a:bodyPr wrap="square" lIns="0" rIns="0" tIns="0" bIns="0">
-            <a:spAutoFit/>
-          </a:bodyPr>
-          <a:lstStyle/>
-          <a:p>
-            <a:pPr algn="l">
-              <a:spcBef>
-                <a:spcPts val="0"/>
-              </a:spcBef>
-              <a:spcAft>
-                <a:spcPts val="600"/>
-              </a:spcAft>
-            </a:pPr>
-            <a:r>
-              <a:rPr sz="1800" b="1" i="0">
-                <a:solidFill>
-                  <a:srgbClr val="18211E"/>
-                </a:solidFill>
-                <a:latin typeface="Georgia"/>
-              </a:rPr>
-              <a:t>Real medical records</a:t>
-            </a:r>
-          </a:p>
-        </p:txBody>
-      </p:sp>
-      <p:sp>
-        <p:nvSpPr>
-          <p:cNvPr id="7" name="TextBox 6"/>
-          <p:cNvSpPr txBox="1"/>
-          <p:nvPr/>
-        </p:nvSpPr>
-        <p:spPr>
-          <a:xfrm>
-            <a:off x="6126480" y="3383280"/>
-            <a:ext cx="5486400" cy="548640"/>
-          </a:xfrm>
-          <a:prstGeom prst="rect">
-            <a:avLst/>
-          </a:prstGeom>
-          <a:noFill/>
-        </p:spPr>
-        <p:txBody>
-          <a:bodyPr wrap="square" lIns="0" rIns="0" tIns="0" bIns="0">
-            <a:spAutoFit/>
-          </a:bodyPr>
-          <a:lstStyle/>
-          <a:p>
-            <a:pPr algn="l">
-              <a:spcBef>
-                <a:spcPts val="0"/>
-              </a:spcBef>
-              <a:spcAft>
-                <a:spcPts val="600"/>
-              </a:spcAft>
-            </a:pPr>
-            <a:r>
-              <a:rPr sz="1600" b="0" i="0">
-                <a:solidFill>
-                  <a:srgbClr val="0F6E5C"/>
-                </a:solidFill>
-                <a:latin typeface="Georgia"/>
-              </a:rPr>
-              <a:t>~80% of personal details swapped</a:t>
-            </a:r>
-          </a:p>
-        </p:txBody>
-      </p:sp>
-      <p:sp>
-        <p:nvSpPr>
-          <p:cNvPr id="8" name="TextBox 7"/>
-          <p:cNvSpPr txBox="1"/>
-          <p:nvPr/>
-        </p:nvSpPr>
-        <p:spPr>
-          <a:xfrm>
-            <a:off x="822960" y="4069080"/>
-            <a:ext cx="5486400" cy="548640"/>
-          </a:xfrm>
-          <a:prstGeom prst="rect">
-            <a:avLst/>
-          </a:prstGeom>
-          <a:noFill/>
-        </p:spPr>
-        <p:txBody>
-          <a:bodyPr wrap="square" lIns="0" rIns="0" tIns="0" bIns="0">
-            <a:spAutoFit/>
-          </a:bodyPr>
-          <a:lstStyle/>
-          <a:p>
-            <a:pPr algn="l">
-              <a:spcBef>
-                <a:spcPts val="0"/>
-              </a:spcBef>
-              <a:spcAft>
-                <a:spcPts val="600"/>
-              </a:spcAft>
-            </a:pPr>
-            <a:r>
-              <a:rPr sz="1800" b="1" i="0">
-                <a:solidFill>
-                  <a:srgbClr val="18211E"/>
-                </a:solidFill>
-                <a:latin typeface="Georgia"/>
-              </a:rPr>
-              <a:t>General / encyclopedic text</a:t>
-            </a:r>
-          </a:p>
-        </p:txBody>
-      </p:sp>
-      <p:sp>
-        <p:nvSpPr>
-          <p:cNvPr id="9" name="TextBox 8"/>
-          <p:cNvSpPr txBox="1"/>
-          <p:nvPr/>
-        </p:nvSpPr>
-        <p:spPr>
-          <a:xfrm>
-            <a:off x="6126480" y="4069080"/>
-            <a:ext cx="5486400" cy="548640"/>
-          </a:xfrm>
-          <a:prstGeom prst="rect">
-            <a:avLst/>
-          </a:prstGeom>
-          <a:noFill/>
-        </p:spPr>
-        <p:txBody>
-          <a:bodyPr wrap="square" lIns="0" rIns="0" tIns="0" bIns="0">
-            <a:spAutoFit/>
-          </a:bodyPr>
-          <a:lstStyle/>
-          <a:p>
-            <a:pPr algn="l">
-              <a:spcBef>
-                <a:spcPts val="0"/>
-              </a:spcBef>
-              <a:spcAft>
-                <a:spcPts val="600"/>
-              </a:spcAft>
-            </a:pPr>
-            <a:r>
-              <a:rPr sz="1600" b="0" i="0">
-                <a:solidFill>
-                  <a:srgbClr val="BD5B36"/>
-                </a:solidFill>
-                <a:latin typeface="Georgia"/>
-              </a:rPr>
-              <a:t>less — those names aren’t private</a:t>
-            </a:r>
-          </a:p>
-        </p:txBody>
-      </p:sp>
-      <p:sp>
-        <p:nvSpPr>
-          <p:cNvPr id="10" name="TextBox 9"/>
-          <p:cNvSpPr txBox="1"/>
-          <p:nvPr/>
-        </p:nvSpPr>
-        <p:spPr>
-          <a:xfrm>
-            <a:off x="640080" y="5212080"/>
-            <a:ext cx="10881360" cy="914400"/>
-          </a:xfrm>
-          <a:prstGeom prst="rect">
-            <a:avLst/>
-          </a:prstGeom>
-          <a:noFill/>
-        </p:spPr>
-        <p:txBody>
-          <a:bodyPr wrap="square" lIns="0" rIns="0" tIns="0" bIns="0">
-            <a:spAutoFit/>
-          </a:bodyPr>
-          <a:lstStyle/>
-          <a:p>
-            <a:pPr algn="l">
-              <a:spcBef>
-                <a:spcPts val="0"/>
-              </a:spcBef>
-              <a:spcAft>
-                <a:spcPts val="600"/>
-              </a:spcAft>
-            </a:pPr>
-            <a:r>
-              <a:rPr sz="1400" b="0" i="0">
-                <a:solidFill>
-                  <a:srgbClr val="5C6B64"/>
-                </a:solidFill>
-                <a:latin typeface="Georgia"/>
-              </a:rPr>
-              <a:t>Important: the “still found 97–100%” result is measured only on the details it does swap — so the two points are kept separate and don’t prop each other up.</a:t>
-            </a:r>
-          </a:p>
-        </p:txBody>
-      </p:sp>
-    </p:spTree>
-  </p:cSld>
-  <p:clrMapOvr>
-    <a:masterClrMapping/>
-  </p:clrMapOvr>
-</p:sld>
-</file>
-
-<file path=ppt/slides/slide6.xml><?xml version="1.0" encoding="utf-8"?>
-<p:sld xmlns:a="http://schemas.openxmlformats.org/drawingml/2006/main" xmlns:p="http://schemas.openxmlformats.org/presentationml/2006/main" xmlns:r="http://schemas.openxmlformats.org/officeDocument/2006/relationships">
-  <p:cSld>
-    <p:spTree>
-      <p:nvGrpSpPr>
-        <p:cNvPr id="1" name=""/>
-        <p:cNvGrpSpPr/>
-        <p:nvPr/>
-      </p:nvGrpSpPr>
-      <p:grpSpPr/>
-      <p:sp>
-        <p:nvSpPr>
-          <p:cNvPr id="2" name="Rectangle 1"/>
-          <p:cNvSpPr/>
-          <p:nvPr/>
-        </p:nvSpPr>
-        <p:spPr>
-          <a:xfrm>
-            <a:off x="0" y="0"/>
-            <a:ext cx="12191695" cy="6858000"/>
-          </a:xfrm>
-          <a:prstGeom prst="rect">
-            <a:avLst/>
-          </a:prstGeom>
-          <a:solidFill>
-            <a:srgbClr val="18211E"/>
-          </a:solidFill>
-          <a:ln>
-            <a:noFill/>
-          </a:ln>
-          <a:effectLst/>
-        </p:spPr>
-        <p:style>
-          <a:lnRef idx="1">
-            <a:schemeClr val="accent1"/>
-          </a:lnRef>
-          <a:fillRef idx="3">
-            <a:schemeClr val="accent1"/>
-          </a:fillRef>
-          <a:effectRef idx="2">
-            <a:schemeClr val="accent1"/>
-          </a:effectRef>
-          <a:fontRef idx="minor">
-            <a:schemeClr val="lt1"/>
-          </a:fontRef>
-        </p:style>
-        <p:txBody>
-          <a:bodyPr rtlCol="0" anchor="ctr"/>
-          <a:lstStyle/>
-          <a:p>
-            <a:pPr algn="ctr"/>
-          </a:p>
-        </p:txBody>
-      </p:sp>
-      <p:sp>
-        <p:nvSpPr>
-          <p:cNvPr id="3" name="TextBox 2"/>
-          <p:cNvSpPr txBox="1"/>
-          <p:nvPr/>
-        </p:nvSpPr>
-        <p:spPr>
-          <a:xfrm>
-            <a:off x="822960" y="2194560"/>
-            <a:ext cx="10515600" cy="2377440"/>
-          </a:xfrm>
-          <a:prstGeom prst="rect">
-            <a:avLst/>
-          </a:prstGeom>
-          <a:noFill/>
-        </p:spPr>
-        <p:txBody>
-          <a:bodyPr wrap="square" lIns="0" rIns="0" tIns="0" bIns="0">
-            <a:spAutoFit/>
-          </a:bodyPr>
-          <a:lstStyle/>
-          <a:p>
-            <a:pPr algn="l">
-              <a:spcBef>
-                <a:spcPts val="0"/>
-              </a:spcBef>
-              <a:spcAft>
-                <a:spcPts val="1400"/>
-              </a:spcAft>
-            </a:pPr>
-            <a:r>
-              <a:rPr sz="1300" b="1" i="0">
-                <a:solidFill>
-                  <a:srgbClr val="0F6E5C"/>
-                </a:solidFill>
-                <a:latin typeface="Consolas"/>
-              </a:rPr>
-              <a:t>Bottom line</a:t>
-            </a:r>
-          </a:p>
-          <a:p>
-            <a:pPr algn="l">
-              <a:spcBef>
-                <a:spcPts val="0"/>
-              </a:spcBef>
-              <a:spcAft>
-                <a:spcPts val="1600"/>
-              </a:spcAft>
-            </a:pPr>
-            <a:r>
-              <a:rPr sz="3200" b="1" i="0">
-                <a:solidFill>
-                  <a:srgbClr val="FFFFFF"/>
-                </a:solidFill>
-                <a:latin typeface="Georgia"/>
-              </a:rPr>
-              <a:t>The swap protects privacy without breaking the data.</a:t>
-            </a:r>
-          </a:p>
-          <a:p>
-            <a:pPr algn="l">
-              <a:spcBef>
-                <a:spcPts val="0"/>
-              </a:spcBef>
-              <a:spcAft>
-                <a:spcPts val="600"/>
-              </a:spcAft>
-            </a:pPr>
-            <a:r>
-              <a:rPr sz="1900" b="0" i="0">
-                <a:solidFill>
-                  <a:srgbClr val="C5CDC8"/>
-                </a:solidFill>
-                <a:latin typeface="Georgia"/>
-              </a:rPr>
-              <a:t>Sensitive details are replaced by realistic stand-ins, the format is preserved exactly, and downstream tools keep working as before.</a:t>
-            </a:r>
-          </a:p>
-        </p:txBody>
-      </p:sp>
-      <p:sp>
-        <p:nvSpPr>
-          <p:cNvPr id="4" name="TextBox 3"/>
-          <p:cNvSpPr txBox="1"/>
-          <p:nvPr/>
-        </p:nvSpPr>
-        <p:spPr>
-          <a:xfrm>
-            <a:off x="822960" y="5486400"/>
-            <a:ext cx="10515600" cy="548640"/>
-          </a:xfrm>
-          <a:prstGeom prst="rect">
-            <a:avLst/>
-          </a:prstGeom>
-          <a:noFill/>
-        </p:spPr>
-        <p:txBody>
-          <a:bodyPr wrap="square" lIns="0" rIns="0" tIns="0" bIns="0">
-            <a:spAutoFit/>
-          </a:bodyPr>
-          <a:lstStyle/>
-          <a:p>
-            <a:pPr algn="l">
-              <a:spcBef>
-                <a:spcPts val="0"/>
-              </a:spcBef>
-              <a:spcAft>
-                <a:spcPts val="600"/>
-              </a:spcAft>
-            </a:pPr>
-            <a:r>
-              <a:rPr sz="1800" b="1" i="0">
-                <a:solidFill>
-                  <a:srgbClr val="0F6E5C"/>
-                </a:solidFill>
-                <a:latin typeface="Consolas"/>
-              </a:rPr>
-              <a:t>See it live → custodianai.pages.dev</a:t>
+              <a:t>custodianai.pages.dev</a:t>
             </a:r>
           </a:p>
         </p:txBody>

</xml_diff>